<commit_message>
feat(site): every joint session given twice (slots A and B on different days), each with its own Teams link; guide PDF and slides rebuilt
Co-Authored-By: Claude Opus 5.5 (1M context) <noreply@anthropic.com>
</commit_message>
<xml_diff>
--- a/docs/slides/COIL_4_final_presentations.pptx
+++ b/docs/slides/COIL_4_final_presentations.pptx
@@ -1701,7 +1701,7 @@
                 <a:ea typeface="Calibri" pitchFamily="34" charset="-122"/>
                 <a:cs typeface="Calibri" pitchFamily="34" charset="-120"/>
               </a:rPr>
-              <a:t>Comparing Europe with Data. Present your project to students and teachers of the three universities. Compulsory to receive the extra points.</a:t>
+              <a:t>Comparing Europe with Data. Present your project to students and teachers of the three universities. Compulsory to receive the extra points. The teachers tell each team in which slot it presents.</a:t>
             </a:r>
             <a:endParaRPr lang="en-US" sz="1600" dirty="0"/>
           </a:p>
@@ -2381,7 +2381,7 @@
                           <a:ea typeface="Calibri" pitchFamily="34" charset="-122"/>
                           <a:cs typeface="Calibri" pitchFamily="34" charset="-120"/>
                         </a:rPr>
-                        <a:t>Team presentations: 5 minutes each + 2 minutes of questions and feedback (about five teams per session).</a:t>
+                        <a:t>Team presentations: 5 minutes each + 2 minutes of questions and feedback (about five teams per slot).</a:t>
                       </a:r>
                       <a:endParaRPr lang="en-US" sz="1150" dirty="0">
                         <a:latin typeface="Calibri" charset="0"/>
@@ -4292,7 +4292,7 @@
                 <a:ea typeface="Calibri" pitchFamily="34" charset="-122"/>
                 <a:cs typeface="Calibri" pitchFamily="34" charset="-120"/>
               </a:rPr>
-              <a:t>Fill in the table when the teams are known. With more than five teams there is a second 45-minute session the same week.</a:t>
+              <a:t>Fill in the table when the teams are known. The session is given in two time slots: about five teams present in each.</a:t>
             </a:r>
             <a:endParaRPr lang="en-US" sz="1100" dirty="0"/>
           </a:p>

</xml_diff>